<commit_message>
Update 릴레이 암송 assets, add ZIP slides, move bible-speed tips
Co-Authored-By: Claude Opus 4.6 (1M context) <noreply@anthropic.com>
</commit_message>
<xml_diff>
--- a/public/downloads/games/bible-relay/rules.pptx
+++ b/public/downloads/games/bible-relay/rules.pptx
@@ -15,20 +15,17 @@
     <p:sldId id="263" r:id="rId13"/>
     <p:sldId id="264" r:id="rId14"/>
     <p:sldId id="265" r:id="rId15"/>
+    <p:sldId id="266" r:id="rId16"/>
   </p:sldIdLst>
   <p:sldSz cx="18288000" cy="10287000"/>
   <p:notesSz cx="6858000" cy="9144000"/>
   <p:embeddedFontLst>
     <p:embeddedFont>
-      <p:font typeface="Jua" charset="1" panose="00000000000000000000"/>
-      <p:regular r:id="rId16"/>
-    </p:embeddedFont>
-    <p:embeddedFont>
-      <p:font typeface="TDTD갬성명조" charset="1" panose="02000503000000000000"/>
+      <p:font typeface="무궁화 고딕" charset="1" panose="02020603020101020101"/>
       <p:regular r:id="rId17"/>
     </p:embeddedFont>
     <p:embeddedFont>
-      <p:font typeface="TDTD가온" charset="1" panose="02000503000000000000"/>
+      <p:font typeface="무궁화 고딕 Bold" charset="1" panose="02020603020101020101"/>
       <p:regular r:id="rId18"/>
     </p:embeddedFont>
   </p:embeddedFontLst>
@@ -3147,8 +3144,8 @@
         </p:nvSpPr>
         <p:spPr>
           <a:xfrm rot="0">
-            <a:off x="1028700" y="3892867"/>
-            <a:ext cx="15555091" cy="2200275"/>
+            <a:off x="1028700" y="4178617"/>
+            <a:ext cx="15555091" cy="1914525"/>
           </a:xfrm>
           <a:prstGeom prst="rect">
             <a:avLst/>
@@ -3170,10 +3167,10 @@
                 <a:solidFill>
                   <a:srgbClr val="FFFAEF"/>
                 </a:solidFill>
-                <a:latin typeface="Jua"/>
-                <a:ea typeface="Jua"/>
-                <a:cs typeface="Jua"/>
-                <a:sym typeface="Jua"/>
+                <a:latin typeface="무궁화 고딕"/>
+                <a:ea typeface="무궁화 고딕"/>
+                <a:cs typeface="무궁화 고딕"/>
+                <a:sym typeface="무궁화 고딕"/>
               </a:rPr>
               <a:t>릴레이 암송</a:t>
             </a:r>
@@ -3188,8 +3185,8 @@
         </p:nvSpPr>
         <p:spPr>
           <a:xfrm rot="0">
-            <a:off x="15264803" y="9812655"/>
-            <a:ext cx="2637975" cy="474345"/>
+            <a:off x="14021540" y="9822180"/>
+            <a:ext cx="3881239" cy="464820"/>
           </a:xfrm>
           <a:prstGeom prst="rect">
             <a:avLst/>
@@ -3214,10 +3211,10 @@
                 <a:solidFill>
                   <a:srgbClr val="FFFFFF"/>
                 </a:solidFill>
-                <a:latin typeface="TDTD갬성명조"/>
-                <a:ea typeface="TDTD갬성명조"/>
-                <a:cs typeface="TDTD갬성명조"/>
-                <a:sym typeface="TDTD갬성명조"/>
+                <a:latin typeface="무궁화 고딕"/>
+                <a:ea typeface="무궁화 고딕"/>
+                <a:cs typeface="무궁화 고딕"/>
+                <a:sym typeface="무궁화 고딕"/>
               </a:rPr>
               <a:t>ⓒ 2026. Sunday Play</a:t>
             </a:r>
@@ -3233,6 +3230,259 @@
 </file>
 
 <file path=ppt/slides/slide10.xml><?xml version="1.0" encoding="utf-8"?>
+<p:sld xmlns:p="http://schemas.openxmlformats.org/presentationml/2006/main" xmlns:a="http://schemas.openxmlformats.org/drawingml/2006/main">
+  <p:cSld>
+    <p:bg>
+      <p:bgPr>
+        <a:solidFill>
+          <a:srgbClr val="FFFAEF"/>
+        </a:solidFill>
+      </p:bgPr>
+    </p:bg>
+    <p:spTree>
+      <p:nvGrpSpPr>
+        <p:cNvPr id="1" name=""/>
+        <p:cNvGrpSpPr/>
+        <p:nvPr/>
+      </p:nvGrpSpPr>
+      <p:grpSpPr>
+        <a:xfrm>
+          <a:off x="0" y="0"/>
+          <a:ext cx="0" cy="0"/>
+          <a:chOff x="0" y="0"/>
+          <a:chExt cx="0" cy="0"/>
+        </a:xfrm>
+      </p:grpSpPr>
+      <p:sp>
+        <p:nvSpPr>
+          <p:cNvPr name="TextBox 2" id="2"/>
+          <p:cNvSpPr txBox="true"/>
+          <p:nvPr/>
+        </p:nvSpPr>
+        <p:spPr>
+          <a:xfrm rot="0">
+            <a:off x="449252" y="747712"/>
+            <a:ext cx="17682365" cy="8791575"/>
+          </a:xfrm>
+          <a:prstGeom prst="rect">
+            <a:avLst/>
+          </a:prstGeom>
+        </p:spPr>
+        <p:txBody>
+          <a:bodyPr anchor="t" rtlCol="false" tIns="0" lIns="0" bIns="0" rIns="0">
+            <a:spAutoFit/>
+          </a:bodyPr>
+          <a:lstStyle/>
+          <a:p>
+            <a:pPr algn="ctr">
+              <a:lnSpc>
+                <a:spcPts val="5399"/>
+              </a:lnSpc>
+            </a:pPr>
+            <a:r>
+              <a:rPr lang="en-US" sz="4499">
+                <a:solidFill>
+                  <a:srgbClr val="000000"/>
+                </a:solidFill>
+                <a:latin typeface="무궁화 고딕"/>
+                <a:ea typeface="무궁화 고딕"/>
+                <a:cs typeface="무궁화 고딕"/>
+                <a:sym typeface="무궁화 고딕"/>
+              </a:rPr>
+              <a:t>4 주 안에서 항상 기뻐하라 내가 다시 말하노니 기뻐하라</a:t>
+            </a:r>
+          </a:p>
+          <a:p>
+            <a:pPr algn="ctr">
+              <a:lnSpc>
+                <a:spcPts val="5399"/>
+              </a:lnSpc>
+            </a:pPr>
+          </a:p>
+          <a:p>
+            <a:pPr algn="ctr">
+              <a:lnSpc>
+                <a:spcPts val="5399"/>
+              </a:lnSpc>
+            </a:pPr>
+            <a:r>
+              <a:rPr lang="en-US" sz="4499">
+                <a:solidFill>
+                  <a:srgbClr val="000000"/>
+                </a:solidFill>
+                <a:latin typeface="무궁화 고딕"/>
+                <a:ea typeface="무궁화 고딕"/>
+                <a:cs typeface="무궁화 고딕"/>
+                <a:sym typeface="무궁화 고딕"/>
+              </a:rPr>
+              <a:t>5 너희 관용을 모든 사람에게 알게 하라 주께서 가까우시니라</a:t>
+            </a:r>
+          </a:p>
+          <a:p>
+            <a:pPr algn="ctr">
+              <a:lnSpc>
+                <a:spcPts val="5399"/>
+              </a:lnSpc>
+            </a:pPr>
+          </a:p>
+          <a:p>
+            <a:pPr algn="ctr">
+              <a:lnSpc>
+                <a:spcPts val="5399"/>
+              </a:lnSpc>
+            </a:pPr>
+            <a:r>
+              <a:rPr lang="en-US" sz="4499">
+                <a:solidFill>
+                  <a:srgbClr val="000000"/>
+                </a:solidFill>
+                <a:latin typeface="무궁화 고딕"/>
+                <a:ea typeface="무궁화 고딕"/>
+                <a:cs typeface="무궁화 고딕"/>
+                <a:sym typeface="무궁화 고딕"/>
+              </a:rPr>
+              <a:t>6 아무 것도 염려하지 말고 다만 모든 일에 기도와 간구로,</a:t>
+            </a:r>
+          </a:p>
+          <a:p>
+            <a:pPr algn="ctr">
+              <a:lnSpc>
+                <a:spcPts val="5399"/>
+              </a:lnSpc>
+            </a:pPr>
+            <a:r>
+              <a:rPr lang="en-US" sz="4499">
+                <a:solidFill>
+                  <a:srgbClr val="000000"/>
+                </a:solidFill>
+                <a:latin typeface="무궁화 고딕"/>
+                <a:ea typeface="무궁화 고딕"/>
+                <a:cs typeface="무궁화 고딕"/>
+                <a:sym typeface="무궁화 고딕"/>
+              </a:rPr>
+              <a:t>너희 구할 것을 감사함으로 하나님께 아뢰라</a:t>
+            </a:r>
+          </a:p>
+          <a:p>
+            <a:pPr algn="ctr">
+              <a:lnSpc>
+                <a:spcPts val="5399"/>
+              </a:lnSpc>
+            </a:pPr>
+          </a:p>
+          <a:p>
+            <a:pPr algn="ctr">
+              <a:lnSpc>
+                <a:spcPts val="5399"/>
+              </a:lnSpc>
+            </a:pPr>
+            <a:r>
+              <a:rPr lang="en-US" sz="4499">
+                <a:solidFill>
+                  <a:srgbClr val="000000"/>
+                </a:solidFill>
+                <a:latin typeface="무궁화 고딕"/>
+                <a:ea typeface="무궁화 고딕"/>
+                <a:cs typeface="무궁화 고딕"/>
+                <a:sym typeface="무궁화 고딕"/>
+              </a:rPr>
+              <a:t>7 그리하면 모든 지각에 뛰어난 하나님의 평강이</a:t>
+            </a:r>
+          </a:p>
+          <a:p>
+            <a:pPr algn="ctr">
+              <a:lnSpc>
+                <a:spcPts val="5399"/>
+              </a:lnSpc>
+            </a:pPr>
+            <a:r>
+              <a:rPr lang="en-US" sz="4499">
+                <a:solidFill>
+                  <a:srgbClr val="000000"/>
+                </a:solidFill>
+                <a:latin typeface="무궁화 고딕"/>
+                <a:ea typeface="무궁화 고딕"/>
+                <a:cs typeface="무궁화 고딕"/>
+                <a:sym typeface="무궁화 고딕"/>
+              </a:rPr>
+              <a:t>그리스도 예수 안에서 너희 마음과 생각을 지키시리라</a:t>
+            </a:r>
+          </a:p>
+          <a:p>
+            <a:pPr algn="ctr">
+              <a:lnSpc>
+                <a:spcPts val="5399"/>
+              </a:lnSpc>
+            </a:pPr>
+          </a:p>
+          <a:p>
+            <a:pPr algn="ctr">
+              <a:lnSpc>
+                <a:spcPts val="5399"/>
+              </a:lnSpc>
+            </a:pPr>
+            <a:r>
+              <a:rPr lang="en-US" sz="4499">
+                <a:solidFill>
+                  <a:srgbClr val="000000"/>
+                </a:solidFill>
+                <a:latin typeface="무궁화 고딕"/>
+                <a:ea typeface="무궁화 고딕"/>
+                <a:cs typeface="무궁화 고딕"/>
+                <a:sym typeface="무궁화 고딕"/>
+              </a:rPr>
+              <a:t>8 끝으로 형제들아 무엇에든지 참되며 무엇에든지 경건하며 무엇에든지</a:t>
+            </a:r>
+          </a:p>
+          <a:p>
+            <a:pPr algn="ctr">
+              <a:lnSpc>
+                <a:spcPts val="5399"/>
+              </a:lnSpc>
+            </a:pPr>
+            <a:r>
+              <a:rPr lang="en-US" sz="4499">
+                <a:solidFill>
+                  <a:srgbClr val="000000"/>
+                </a:solidFill>
+                <a:latin typeface="무궁화 고딕"/>
+                <a:ea typeface="무궁화 고딕"/>
+                <a:cs typeface="무궁화 고딕"/>
+                <a:sym typeface="무궁화 고딕"/>
+              </a:rPr>
+              <a:t>옳으며 무엇에든지 정결하며 무엇에든지 사랑받을 만하며 무엇에든지</a:t>
+            </a:r>
+          </a:p>
+          <a:p>
+            <a:pPr algn="ctr">
+              <a:lnSpc>
+                <a:spcPts val="5399"/>
+              </a:lnSpc>
+            </a:pPr>
+            <a:r>
+              <a:rPr lang="en-US" sz="4499">
+                <a:solidFill>
+                  <a:srgbClr val="000000"/>
+                </a:solidFill>
+                <a:latin typeface="무궁화 고딕"/>
+                <a:ea typeface="무궁화 고딕"/>
+                <a:cs typeface="무궁화 고딕"/>
+                <a:sym typeface="무궁화 고딕"/>
+              </a:rPr>
+              <a:t>칭찬받을 만하며 무슨 덕이 있든지 무슨 기림이 있든지 이것들을 생각하라</a:t>
+            </a:r>
+          </a:p>
+        </p:txBody>
+      </p:sp>
+    </p:spTree>
+  </p:cSld>
+  <p:clrMapOvr>
+    <a:masterClrMapping/>
+  </p:clrMapOvr>
+</p:sld>
+</file>
+
+<file path=ppt/slides/slide11.xml><?xml version="1.0" encoding="utf-8"?>
 <p:sld xmlns:p="http://schemas.openxmlformats.org/presentationml/2006/main" xmlns:a="http://schemas.openxmlformats.org/drawingml/2006/main" xmlns:r="http://schemas.openxmlformats.org/officeDocument/2006/relationships">
   <p:cSld>
     <p:bg>
@@ -3289,8 +3539,8 @@
         </p:nvSpPr>
         <p:spPr>
           <a:xfrm rot="0">
-            <a:off x="4421807" y="3895725"/>
-            <a:ext cx="9444385" cy="2200275"/>
+            <a:off x="4421807" y="4181475"/>
+            <a:ext cx="9444385" cy="1914525"/>
           </a:xfrm>
           <a:prstGeom prst="rect">
             <a:avLst/>
@@ -3312,10 +3562,10 @@
                 <a:solidFill>
                   <a:srgbClr val="000000"/>
                 </a:solidFill>
-                <a:latin typeface="Jua"/>
-                <a:ea typeface="Jua"/>
-                <a:cs typeface="Jua"/>
-                <a:sym typeface="Jua"/>
+                <a:latin typeface="무궁화 고딕"/>
+                <a:ea typeface="무궁화 고딕"/>
+                <a:cs typeface="무궁화 고딕"/>
+                <a:sym typeface="무궁화 고딕"/>
               </a:rPr>
               <a:t>감사합니다!</a:t>
             </a:r>
@@ -3514,8 +3764,8 @@
         </p:nvSpPr>
         <p:spPr>
           <a:xfrm rot="0">
-            <a:off x="11392761" y="600705"/>
-            <a:ext cx="5362043" cy="1600200"/>
+            <a:off x="11392761" y="819780"/>
+            <a:ext cx="5362043" cy="1381125"/>
           </a:xfrm>
           <a:prstGeom prst="rect">
             <a:avLst/>
@@ -3537,10 +3787,10 @@
                 <a:solidFill>
                   <a:srgbClr val="FFFAEF"/>
                 </a:solidFill>
-                <a:latin typeface="Jua"/>
-                <a:ea typeface="Jua"/>
-                <a:cs typeface="Jua"/>
-                <a:sym typeface="Jua"/>
+                <a:latin typeface="무궁화 고딕"/>
+                <a:ea typeface="무궁화 고딕"/>
+                <a:cs typeface="무궁화 고딕"/>
+                <a:sym typeface="무궁화 고딕"/>
               </a:rPr>
               <a:t>규칙</a:t>
             </a:r>
@@ -3556,9 +3806,9 @@
         <p:grpSpPr>
           <a:xfrm rot="0">
             <a:off x="217650" y="223900"/>
-            <a:ext cx="10360529" cy="2942330"/>
+            <a:ext cx="10360529" cy="2601393"/>
             <a:chOff x="0" y="0"/>
-            <a:chExt cx="13814039" cy="3923107"/>
+            <a:chExt cx="13814039" cy="3468524"/>
           </a:xfrm>
         </p:grpSpPr>
         <p:sp>
@@ -3569,8 +3819,8 @@
           </p:nvSpPr>
           <p:spPr>
             <a:xfrm rot="0">
-              <a:off x="0" y="1625465"/>
-              <a:ext cx="13814039" cy="2297642"/>
+              <a:off x="0" y="1648191"/>
+              <a:ext cx="13814039" cy="1820333"/>
             </a:xfrm>
             <a:prstGeom prst="rect">
               <a:avLst/>
@@ -3584,18 +3834,18 @@
             <a:p>
               <a:pPr algn="l">
                 <a:lnSpc>
-                  <a:spcPts val="7000"/>
+                  <a:spcPts val="5599"/>
                 </a:lnSpc>
               </a:pPr>
               <a:r>
-                <a:rPr lang="en-US" sz="5000">
+                <a:rPr lang="en-US" sz="3999">
                   <a:solidFill>
                     <a:srgbClr val="FFFAEF"/>
                   </a:solidFill>
-                  <a:latin typeface="TDTD가온"/>
-                  <a:ea typeface="TDTD가온"/>
-                  <a:cs typeface="TDTD가온"/>
-                  <a:sym typeface="TDTD가온"/>
+                  <a:latin typeface="무궁화 고딕"/>
+                  <a:ea typeface="무궁화 고딕"/>
+                  <a:cs typeface="무궁화 고딕"/>
+                  <a:sym typeface="무궁화 고딕"/>
                 </a:rPr>
                 <a:t>팀별로 성경 구절을</a:t>
               </a:r>
@@ -3603,18 +3853,18 @@
             <a:p>
               <a:pPr algn="l">
                 <a:lnSpc>
-                  <a:spcPts val="7000"/>
+                  <a:spcPts val="5599"/>
                 </a:lnSpc>
               </a:pPr>
               <a:r>
-                <a:rPr lang="en-US" sz="5000">
+                <a:rPr lang="en-US" sz="3999">
                   <a:solidFill>
                     <a:srgbClr val="FFFAEF"/>
                   </a:solidFill>
-                  <a:latin typeface="TDTD가온"/>
-                  <a:ea typeface="TDTD가온"/>
-                  <a:cs typeface="TDTD가온"/>
-                  <a:sym typeface="TDTD가온"/>
+                  <a:latin typeface="무궁화 고딕"/>
+                  <a:ea typeface="무궁화 고딕"/>
+                  <a:cs typeface="무궁화 고딕"/>
+                  <a:sym typeface="무궁화 고딕"/>
                 </a:rPr>
                 <a:t>문장 단위로 나눠 분담합니다.</a:t>
               </a:r>
@@ -3629,8 +3879,8 @@
           </p:nvSpPr>
           <p:spPr>
             <a:xfrm rot="0">
-              <a:off x="0" y="-190500"/>
-              <a:ext cx="11298371" cy="1367863"/>
+              <a:off x="0" y="-66675"/>
+              <a:ext cx="11298371" cy="1238189"/>
             </a:xfrm>
             <a:prstGeom prst="rect">
               <a:avLst/>
@@ -3652,10 +3902,10 @@
                   <a:solidFill>
                     <a:srgbClr val="FFFAEF"/>
                   </a:solidFill>
-                  <a:latin typeface="Jua"/>
-                  <a:ea typeface="Jua"/>
-                  <a:cs typeface="Jua"/>
-                  <a:sym typeface="Jua"/>
+                  <a:latin typeface="무궁화 고딕 Bold"/>
+                  <a:ea typeface="무궁화 고딕 Bold"/>
+                  <a:cs typeface="무궁화 고딕 Bold"/>
+                  <a:sym typeface="무궁화 고딕 Bold"/>
                 </a:rPr>
                 <a:t>STEP 1.</a:t>
               </a:r>
@@ -3671,10 +3921,10 @@
         </p:nvGrpSpPr>
         <p:grpSpPr>
           <a:xfrm rot="0">
-            <a:off x="9144000" y="7809938"/>
-            <a:ext cx="9144000" cy="1994512"/>
+            <a:off x="9545053" y="8200435"/>
+            <a:ext cx="8422105" cy="1838937"/>
             <a:chOff x="0" y="0"/>
-            <a:chExt cx="12192000" cy="2659349"/>
+            <a:chExt cx="11229474" cy="2451916"/>
           </a:xfrm>
         </p:grpSpPr>
         <p:sp>
@@ -3685,8 +3935,8 @@
           </p:nvSpPr>
           <p:spPr>
             <a:xfrm rot="0">
-              <a:off x="0" y="1542808"/>
-              <a:ext cx="12076089" cy="1116541"/>
+              <a:off x="0" y="1571383"/>
+              <a:ext cx="11122714" cy="880533"/>
             </a:xfrm>
             <a:prstGeom prst="rect">
               <a:avLst/>
@@ -3700,18 +3950,18 @@
             <a:p>
               <a:pPr algn="l">
                 <a:lnSpc>
-                  <a:spcPts val="7000"/>
+                  <a:spcPts val="5599"/>
                 </a:lnSpc>
               </a:pPr>
               <a:r>
-                <a:rPr lang="en-US" sz="5000">
+                <a:rPr lang="en-US" sz="3999">
                   <a:solidFill>
                     <a:srgbClr val="FFFAEF"/>
                   </a:solidFill>
-                  <a:latin typeface="TDTD가온"/>
-                  <a:ea typeface="TDTD가온"/>
-                  <a:cs typeface="TDTD가온"/>
-                  <a:sym typeface="TDTD가온"/>
+                  <a:latin typeface="무궁화 고딕"/>
+                  <a:ea typeface="무궁화 고딕"/>
+                  <a:cs typeface="무궁화 고딕"/>
+                  <a:sym typeface="무궁화 고딕"/>
                 </a:rPr>
                 <a:t>가장 정확하고 빠르게 암송한 팀이 우승!</a:t>
               </a:r>
@@ -3726,8 +3976,8 @@
           </p:nvSpPr>
           <p:spPr>
             <a:xfrm rot="0">
-              <a:off x="0" y="-190500"/>
-              <a:ext cx="12192000" cy="1374479"/>
+              <a:off x="0" y="-57150"/>
+              <a:ext cx="11229474" cy="1241129"/>
             </a:xfrm>
             <a:prstGeom prst="rect">
               <a:avLst/>
@@ -3749,10 +3999,10 @@
                   <a:solidFill>
                     <a:srgbClr val="FFFAEF"/>
                   </a:solidFill>
-                  <a:latin typeface="Jua"/>
-                  <a:ea typeface="Jua"/>
-                  <a:cs typeface="Jua"/>
-                  <a:sym typeface="Jua"/>
+                  <a:latin typeface="무궁화 고딕 Bold"/>
+                  <a:ea typeface="무궁화 고딕 Bold"/>
+                  <a:cs typeface="무궁화 고딕 Bold"/>
+                  <a:sym typeface="무궁화 고딕 Bold"/>
                 </a:rPr>
                 <a:t>STEP 3.</a:t>
               </a:r>
@@ -3768,10 +4018,10 @@
         </p:nvGrpSpPr>
         <p:grpSpPr>
           <a:xfrm rot="0">
-            <a:off x="5264876" y="4018325"/>
-            <a:ext cx="9376340" cy="2939517"/>
+            <a:off x="5144560" y="3902254"/>
+            <a:ext cx="9376340" cy="2596832"/>
             <a:chOff x="0" y="0"/>
-            <a:chExt cx="12501787" cy="3919356"/>
+            <a:chExt cx="12501787" cy="3462442"/>
           </a:xfrm>
         </p:grpSpPr>
         <p:sp>
@@ -3782,8 +4032,8 @@
           </p:nvSpPr>
           <p:spPr>
             <a:xfrm rot="0">
-              <a:off x="0" y="1631121"/>
-              <a:ext cx="12501787" cy="2288235"/>
+              <a:off x="0" y="1642109"/>
+              <a:ext cx="12501787" cy="1820333"/>
             </a:xfrm>
             <a:prstGeom prst="rect">
               <a:avLst/>
@@ -3797,18 +4047,18 @@
             <a:p>
               <a:pPr algn="l">
                 <a:lnSpc>
-                  <a:spcPts val="6995"/>
+                  <a:spcPts val="5599"/>
                 </a:lnSpc>
               </a:pPr>
               <a:r>
-                <a:rPr lang="en-US" sz="4996">
+                <a:rPr lang="en-US" sz="3999">
                   <a:solidFill>
                     <a:srgbClr val="FFFAEF"/>
                   </a:solidFill>
-                  <a:latin typeface="TDTD가온"/>
-                  <a:ea typeface="TDTD가온"/>
-                  <a:cs typeface="TDTD가온"/>
-                  <a:sym typeface="TDTD가온"/>
+                  <a:latin typeface="무궁화 고딕"/>
+                  <a:ea typeface="무궁화 고딕"/>
+                  <a:cs typeface="무궁화 고딕"/>
+                  <a:sym typeface="무궁화 고딕"/>
                 </a:rPr>
                 <a:t>준비가 되면 팀별로 순서대로 이어서</a:t>
               </a:r>
@@ -3816,18 +4066,18 @@
             <a:p>
               <a:pPr algn="l">
                 <a:lnSpc>
-                  <a:spcPts val="6995"/>
+                  <a:spcPts val="5599"/>
                 </a:lnSpc>
               </a:pPr>
               <a:r>
-                <a:rPr lang="en-US" sz="4996">
+                <a:rPr lang="en-US" sz="3999">
                   <a:solidFill>
                     <a:srgbClr val="FFFAEF"/>
                   </a:solidFill>
-                  <a:latin typeface="TDTD가온"/>
-                  <a:ea typeface="TDTD가온"/>
-                  <a:cs typeface="TDTD가온"/>
-                  <a:sym typeface="TDTD가온"/>
+                  <a:latin typeface="무궁화 고딕"/>
+                  <a:ea typeface="무궁화 고딕"/>
+                  <a:cs typeface="무궁화 고딕"/>
+                  <a:sym typeface="무궁화 고딕"/>
                 </a:rPr>
                 <a:t>암송합니다.</a:t>
               </a:r>
@@ -3842,8 +4092,8 @@
           </p:nvSpPr>
           <p:spPr>
             <a:xfrm rot="0">
-              <a:off x="0" y="-190500"/>
-              <a:ext cx="5178984" cy="1369906"/>
+              <a:off x="0" y="-66675"/>
+              <a:ext cx="5178984" cy="1238018"/>
             </a:xfrm>
             <a:prstGeom prst="rect">
               <a:avLst/>
@@ -3865,10 +4115,10 @@
                   <a:solidFill>
                     <a:srgbClr val="FFFAEF"/>
                   </a:solidFill>
-                  <a:latin typeface="Jua"/>
-                  <a:ea typeface="Jua"/>
-                  <a:cs typeface="Jua"/>
-                  <a:sym typeface="Jua"/>
+                  <a:latin typeface="무궁화 고딕 Bold"/>
+                  <a:ea typeface="무궁화 고딕 Bold"/>
+                  <a:cs typeface="무궁화 고딕 Bold"/>
+                  <a:sym typeface="무궁화 고딕 Bold"/>
                 </a:rPr>
                 <a:t>STEP 2.</a:t>
               </a:r>
@@ -3885,6 +4135,129 @@
 </file>
 
 <file path=ppt/slides/slide3.xml><?xml version="1.0" encoding="utf-8"?>
+<p:sld xmlns:p="http://schemas.openxmlformats.org/presentationml/2006/main" xmlns:a="http://schemas.openxmlformats.org/drawingml/2006/main" xmlns:r="http://schemas.openxmlformats.org/officeDocument/2006/relationships">
+  <p:cSld>
+    <p:bg>
+      <p:bgPr>
+        <a:solidFill>
+          <a:srgbClr val="FFFAEF"/>
+        </a:solidFill>
+      </p:bgPr>
+    </p:bg>
+    <p:spTree>
+      <p:nvGrpSpPr>
+        <p:cNvPr id="1" name=""/>
+        <p:cNvGrpSpPr/>
+        <p:nvPr/>
+      </p:nvGrpSpPr>
+      <p:grpSpPr>
+        <a:xfrm>
+          <a:off x="0" y="0"/>
+          <a:ext cx="0" cy="0"/>
+          <a:chOff x="0" y="0"/>
+          <a:chExt cx="0" cy="0"/>
+        </a:xfrm>
+      </p:grpSpPr>
+      <p:sp>
+        <p:nvSpPr>
+          <p:cNvPr name="TextBox 2" id="2"/>
+          <p:cNvSpPr txBox="true"/>
+          <p:nvPr/>
+        </p:nvSpPr>
+        <p:spPr>
+          <a:xfrm rot="0">
+            <a:off x="3238925" y="4378545"/>
+            <a:ext cx="11810151" cy="1914525"/>
+          </a:xfrm>
+          <a:prstGeom prst="rect">
+            <a:avLst/>
+          </a:prstGeom>
+        </p:spPr>
+        <p:txBody>
+          <a:bodyPr anchor="t" rtlCol="false" tIns="0" lIns="0" bIns="0" rIns="0">
+            <a:spAutoFit/>
+          </a:bodyPr>
+          <a:lstStyle/>
+          <a:p>
+            <a:pPr algn="ctr">
+              <a:lnSpc>
+                <a:spcPts val="15000"/>
+              </a:lnSpc>
+            </a:pPr>
+            <a:r>
+              <a:rPr lang="en-US" sz="12500">
+                <a:solidFill>
+                  <a:srgbClr val="000000"/>
+                </a:solidFill>
+                <a:latin typeface="무궁화 고딕"/>
+                <a:ea typeface="무궁화 고딕"/>
+                <a:cs typeface="무궁화 고딕"/>
+                <a:sym typeface="무궁화 고딕"/>
+              </a:rPr>
+              <a:t>팀을 나눠주세요!</a:t>
+            </a:r>
+          </a:p>
+        </p:txBody>
+      </p:sp>
+      <p:pic>
+        <p:nvPicPr>
+          <p:cNvPr name="Picture 3" id="3"/>
+          <p:cNvPicPr>
+            <a:picLocks noChangeAspect="true"/>
+          </p:cNvPicPr>
+          <p:nvPr/>
+        </p:nvPicPr>
+        <p:blipFill>
+          <a:blip r:embed="rId2"/>
+          <a:srcRect l="0" t="0" r="0" b="0"/>
+          <a:stretch>
+            <a:fillRect/>
+          </a:stretch>
+        </p:blipFill>
+        <p:spPr>
+          <a:xfrm flipH="false" flipV="false" rot="0">
+            <a:off x="13655377" y="6809666"/>
+            <a:ext cx="6229999" cy="6954669"/>
+          </a:xfrm>
+          <a:prstGeom prst="rect">
+            <a:avLst/>
+          </a:prstGeom>
+        </p:spPr>
+      </p:pic>
+      <p:pic>
+        <p:nvPicPr>
+          <p:cNvPr name="Picture 4" id="4"/>
+          <p:cNvPicPr>
+            <a:picLocks noChangeAspect="true"/>
+          </p:cNvPicPr>
+          <p:nvPr/>
+        </p:nvPicPr>
+        <p:blipFill>
+          <a:blip r:embed="rId3"/>
+          <a:srcRect l="0" t="0" r="0" b="0"/>
+          <a:stretch>
+            <a:fillRect/>
+          </a:stretch>
+        </p:blipFill>
+        <p:spPr>
+          <a:xfrm flipH="false" flipV="false" rot="0">
+            <a:off x="0" y="0"/>
+            <a:ext cx="6925457" cy="4700654"/>
+          </a:xfrm>
+          <a:prstGeom prst="rect">
+            <a:avLst/>
+          </a:prstGeom>
+        </p:spPr>
+      </p:pic>
+    </p:spTree>
+  </p:cSld>
+  <p:clrMapOvr>
+    <a:masterClrMapping/>
+  </p:clrMapOvr>
+</p:sld>
+</file>
+
+<file path=ppt/slides/slide4.xml><?xml version="1.0" encoding="utf-8"?>
 <p:sld xmlns:p="http://schemas.openxmlformats.org/presentationml/2006/main" xmlns:a="http://schemas.openxmlformats.org/drawingml/2006/main" xmlns:r="http://schemas.openxmlformats.org/officeDocument/2006/relationships">
   <p:cSld>
     <p:bg>
@@ -3966,8 +4339,8 @@
         </p:nvSpPr>
         <p:spPr>
           <a:xfrm rot="0">
-            <a:off x="1028700" y="3892867"/>
-            <a:ext cx="15555091" cy="2200275"/>
+            <a:off x="1028700" y="4178617"/>
+            <a:ext cx="15555091" cy="1914525"/>
           </a:xfrm>
           <a:prstGeom prst="rect">
             <a:avLst/>
@@ -3989,10 +4362,10 @@
                 <a:solidFill>
                   <a:srgbClr val="FFFAEF"/>
                 </a:solidFill>
-                <a:latin typeface="Jua"/>
-                <a:ea typeface="Jua"/>
-                <a:cs typeface="Jua"/>
-                <a:sym typeface="Jua"/>
+                <a:latin typeface="무궁화 고딕"/>
+                <a:ea typeface="무궁화 고딕"/>
+                <a:cs typeface="무궁화 고딕"/>
+                <a:sym typeface="무궁화 고딕"/>
               </a:rPr>
               <a:t>릴레이 암송</a:t>
             </a:r>
@@ -4007,8 +4380,8 @@
         </p:nvSpPr>
         <p:spPr>
           <a:xfrm rot="0">
-            <a:off x="15264803" y="9812655"/>
-            <a:ext cx="2637975" cy="474345"/>
+            <a:off x="14021540" y="9822180"/>
+            <a:ext cx="3881239" cy="464820"/>
           </a:xfrm>
           <a:prstGeom prst="rect">
             <a:avLst/>
@@ -4033,10 +4406,10 @@
                 <a:solidFill>
                   <a:srgbClr val="FFFFFF"/>
                 </a:solidFill>
-                <a:latin typeface="TDTD갬성명조"/>
-                <a:ea typeface="TDTD갬성명조"/>
-                <a:cs typeface="TDTD갬성명조"/>
-                <a:sym typeface="TDTD갬성명조"/>
+                <a:latin typeface="무궁화 고딕"/>
+                <a:ea typeface="무궁화 고딕"/>
+                <a:cs typeface="무궁화 고딕"/>
+                <a:sym typeface="무궁화 고딕"/>
               </a:rPr>
               <a:t>ⓒ 2026. Sunday Play</a:t>
             </a:r>
@@ -4051,7 +4424,7 @@
 </p:sld>
 </file>
 
-<file path=ppt/slides/slide4.xml><?xml version="1.0" encoding="utf-8"?>
+<file path=ppt/slides/slide5.xml><?xml version="1.0" encoding="utf-8"?>
 <p:sld xmlns:p="http://schemas.openxmlformats.org/presentationml/2006/main" xmlns:a="http://schemas.openxmlformats.org/drawingml/2006/main" xmlns:r="http://schemas.openxmlformats.org/officeDocument/2006/relationships">
   <p:cSld>
     <p:bg>
@@ -4133,8 +4506,8 @@
         </p:nvSpPr>
         <p:spPr>
           <a:xfrm rot="0">
-            <a:off x="2717556" y="2943225"/>
-            <a:ext cx="12852888" cy="4105275"/>
+            <a:off x="2717556" y="3228975"/>
+            <a:ext cx="12852888" cy="3819525"/>
           </a:xfrm>
           <a:prstGeom prst="rect">
             <a:avLst/>
@@ -4156,10 +4529,10 @@
                 <a:solidFill>
                   <a:srgbClr val="000000"/>
                 </a:solidFill>
-                <a:latin typeface="Jua"/>
-                <a:ea typeface="Jua"/>
-                <a:cs typeface="Jua"/>
-                <a:sym typeface="Jua"/>
+                <a:latin typeface="무궁화 고딕"/>
+                <a:ea typeface="무궁화 고딕"/>
+                <a:cs typeface="무궁화 고딕"/>
+                <a:sym typeface="무궁화 고딕"/>
               </a:rPr>
               <a:t>[ 1 Round ] </a:t>
             </a:r>
@@ -4175,10 +4548,10 @@
                 <a:solidFill>
                   <a:srgbClr val="000000"/>
                 </a:solidFill>
-                <a:latin typeface="Jua"/>
-                <a:ea typeface="Jua"/>
-                <a:cs typeface="Jua"/>
-                <a:sym typeface="Jua"/>
+                <a:latin typeface="무궁화 고딕"/>
+                <a:ea typeface="무궁화 고딕"/>
+                <a:cs typeface="무궁화 고딕"/>
+                <a:sym typeface="무궁화 고딕"/>
               </a:rPr>
               <a:t>고린도전서 13:4-8</a:t>
             </a:r>
@@ -4193,7 +4566,7 @@
 </p:sld>
 </file>
 
-<file path=ppt/slides/slide5.xml><?xml version="1.0" encoding="utf-8"?>
+<file path=ppt/slides/slide6.xml><?xml version="1.0" encoding="utf-8"?>
 <p:sld xmlns:p="http://schemas.openxmlformats.org/presentationml/2006/main" xmlns:a="http://schemas.openxmlformats.org/drawingml/2006/main">
   <p:cSld>
     <p:bg>
@@ -4225,8 +4598,8 @@
         </p:nvSpPr>
         <p:spPr>
           <a:xfrm rot="0">
-            <a:off x="302818" y="4763"/>
-            <a:ext cx="17682365" cy="10153650"/>
+            <a:off x="302818" y="119063"/>
+            <a:ext cx="17682365" cy="10039350"/>
           </a:xfrm>
           <a:prstGeom prst="rect">
             <a:avLst/>
@@ -4248,10 +4621,10 @@
                 <a:solidFill>
                   <a:srgbClr val="000000"/>
                 </a:solidFill>
-                <a:latin typeface="Jua"/>
-                <a:ea typeface="Jua"/>
-                <a:cs typeface="Jua"/>
-                <a:sym typeface="Jua"/>
+                <a:latin typeface="무궁화 고딕"/>
+                <a:ea typeface="무궁화 고딕"/>
+                <a:cs typeface="무궁화 고딕"/>
+                <a:sym typeface="무궁화 고딕"/>
               </a:rPr>
               <a:t>4 사랑은 오래 참고 사랑은 온유하며 시기하지 아니하며</a:t>
             </a:r>
@@ -4267,10 +4640,10 @@
                 <a:solidFill>
                   <a:srgbClr val="000000"/>
                 </a:solidFill>
-                <a:latin typeface="Jua"/>
-                <a:ea typeface="Jua"/>
-                <a:cs typeface="Jua"/>
-                <a:sym typeface="Jua"/>
+                <a:latin typeface="무궁화 고딕"/>
+                <a:ea typeface="무궁화 고딕"/>
+                <a:cs typeface="무궁화 고딕"/>
+                <a:sym typeface="무궁화 고딕"/>
               </a:rPr>
               <a:t>사랑은 자랑하지 아니하며 교만하지 아니하며</a:t>
             </a:r>
@@ -4293,10 +4666,10 @@
                 <a:solidFill>
                   <a:srgbClr val="000000"/>
                 </a:solidFill>
-                <a:latin typeface="Jua"/>
-                <a:ea typeface="Jua"/>
-                <a:cs typeface="Jua"/>
-                <a:sym typeface="Jua"/>
+                <a:latin typeface="무궁화 고딕"/>
+                <a:ea typeface="무궁화 고딕"/>
+                <a:cs typeface="무궁화 고딕"/>
+                <a:sym typeface="무궁화 고딕"/>
               </a:rPr>
               <a:t>5 무례히 행하지 아니하며 자기의 유익을 구하지 아니하며</a:t>
             </a:r>
@@ -4312,10 +4685,10 @@
                 <a:solidFill>
                   <a:srgbClr val="000000"/>
                 </a:solidFill>
-                <a:latin typeface="Jua"/>
-                <a:ea typeface="Jua"/>
-                <a:cs typeface="Jua"/>
-                <a:sym typeface="Jua"/>
+                <a:latin typeface="무궁화 고딕"/>
+                <a:ea typeface="무궁화 고딕"/>
+                <a:cs typeface="무궁화 고딕"/>
+                <a:sym typeface="무궁화 고딕"/>
               </a:rPr>
               <a:t>성내지 아니하며 악한 것을 생각하지 아니하며</a:t>
             </a:r>
@@ -4338,10 +4711,10 @@
                 <a:solidFill>
                   <a:srgbClr val="000000"/>
                 </a:solidFill>
-                <a:latin typeface="Jua"/>
-                <a:ea typeface="Jua"/>
-                <a:cs typeface="Jua"/>
-                <a:sym typeface="Jua"/>
+                <a:latin typeface="무궁화 고딕"/>
+                <a:ea typeface="무궁화 고딕"/>
+                <a:cs typeface="무궁화 고딕"/>
+                <a:sym typeface="무궁화 고딕"/>
               </a:rPr>
               <a:t>6 불의를 기뻐하지 아니하며 진리와 함께 기뻐하고</a:t>
             </a:r>
@@ -4364,10 +4737,10 @@
                 <a:solidFill>
                   <a:srgbClr val="000000"/>
                 </a:solidFill>
-                <a:latin typeface="Jua"/>
-                <a:ea typeface="Jua"/>
-                <a:cs typeface="Jua"/>
-                <a:sym typeface="Jua"/>
+                <a:latin typeface="무궁화 고딕"/>
+                <a:ea typeface="무궁화 고딕"/>
+                <a:cs typeface="무궁화 고딕"/>
+                <a:sym typeface="무궁화 고딕"/>
               </a:rPr>
               <a:t>7 모든 것을 참으며 모든 것을 믿으며</a:t>
             </a:r>
@@ -4383,10 +4756,10 @@
                 <a:solidFill>
                   <a:srgbClr val="000000"/>
                 </a:solidFill>
-                <a:latin typeface="Jua"/>
-                <a:ea typeface="Jua"/>
-                <a:cs typeface="Jua"/>
-                <a:sym typeface="Jua"/>
+                <a:latin typeface="무궁화 고딕"/>
+                <a:ea typeface="무궁화 고딕"/>
+                <a:cs typeface="무궁화 고딕"/>
+                <a:sym typeface="무궁화 고딕"/>
               </a:rPr>
               <a:t>모든 것을 바라며 모든 것을 견디느니라</a:t>
             </a:r>
@@ -4409,10 +4782,10 @@
                 <a:solidFill>
                   <a:srgbClr val="000000"/>
                 </a:solidFill>
-                <a:latin typeface="Jua"/>
-                <a:ea typeface="Jua"/>
-                <a:cs typeface="Jua"/>
-                <a:sym typeface="Jua"/>
+                <a:latin typeface="무궁화 고딕"/>
+                <a:ea typeface="무궁화 고딕"/>
+                <a:cs typeface="무궁화 고딕"/>
+                <a:sym typeface="무궁화 고딕"/>
               </a:rPr>
               <a:t>8 사랑은 언제까지나 떨어지지 아니하되</a:t>
             </a:r>
@@ -4428,10 +4801,10 @@
                 <a:solidFill>
                   <a:srgbClr val="000000"/>
                 </a:solidFill>
-                <a:latin typeface="Jua"/>
-                <a:ea typeface="Jua"/>
-                <a:cs typeface="Jua"/>
-                <a:sym typeface="Jua"/>
+                <a:latin typeface="무궁화 고딕"/>
+                <a:ea typeface="무궁화 고딕"/>
+                <a:cs typeface="무궁화 고딕"/>
+                <a:sym typeface="무궁화 고딕"/>
               </a:rPr>
               <a:t>예언도 폐하고 방언도 그치고 지식도 폐하리라</a:t>
             </a:r>
@@ -4446,7 +4819,7 @@
 </p:sld>
 </file>
 
-<file path=ppt/slides/slide6.xml><?xml version="1.0" encoding="utf-8"?>
+<file path=ppt/slides/slide7.xml><?xml version="1.0" encoding="utf-8"?>
 <p:sld xmlns:p="http://schemas.openxmlformats.org/presentationml/2006/main" xmlns:a="http://schemas.openxmlformats.org/drawingml/2006/main" xmlns:r="http://schemas.openxmlformats.org/officeDocument/2006/relationships">
   <p:cSld>
     <p:bg>
@@ -4528,8 +4901,8 @@
         </p:nvSpPr>
         <p:spPr>
           <a:xfrm rot="0">
-            <a:off x="2717556" y="2943225"/>
-            <a:ext cx="12852888" cy="4105275"/>
+            <a:off x="2717556" y="3228975"/>
+            <a:ext cx="12852888" cy="3819525"/>
           </a:xfrm>
           <a:prstGeom prst="rect">
             <a:avLst/>
@@ -4551,10 +4924,10 @@
                 <a:solidFill>
                   <a:srgbClr val="000000"/>
                 </a:solidFill>
-                <a:latin typeface="Jua"/>
-                <a:ea typeface="Jua"/>
-                <a:cs typeface="Jua"/>
-                <a:sym typeface="Jua"/>
+                <a:latin typeface="무궁화 고딕"/>
+                <a:ea typeface="무궁화 고딕"/>
+                <a:cs typeface="무궁화 고딕"/>
+                <a:sym typeface="무궁화 고딕"/>
               </a:rPr>
               <a:t>[ 2 Round ] </a:t>
             </a:r>
@@ -4570,10 +4943,10 @@
                 <a:solidFill>
                   <a:srgbClr val="000000"/>
                 </a:solidFill>
-                <a:latin typeface="Jua"/>
-                <a:ea typeface="Jua"/>
-                <a:cs typeface="Jua"/>
-                <a:sym typeface="Jua"/>
+                <a:latin typeface="무궁화 고딕"/>
+                <a:ea typeface="무궁화 고딕"/>
+                <a:cs typeface="무궁화 고딕"/>
+                <a:sym typeface="무궁화 고딕"/>
               </a:rPr>
               <a:t>시편</a:t>
             </a:r>
@@ -4582,10 +4955,10 @@
                 <a:solidFill>
                   <a:srgbClr val="000000"/>
                 </a:solidFill>
-                <a:latin typeface="Jua"/>
-                <a:ea typeface="Jua"/>
-                <a:cs typeface="Jua"/>
-                <a:sym typeface="Jua"/>
+                <a:latin typeface="무궁화 고딕"/>
+                <a:ea typeface="무궁화 고딕"/>
+                <a:cs typeface="무궁화 고딕"/>
+                <a:sym typeface="무궁화 고딕"/>
               </a:rPr>
               <a:t> 23:1-6</a:t>
             </a:r>
@@ -4600,7 +4973,7 @@
 </p:sld>
 </file>
 
-<file path=ppt/slides/slide7.xml><?xml version="1.0" encoding="utf-8"?>
+<file path=ppt/slides/slide8.xml><?xml version="1.0" encoding="utf-8"?>
 <p:sld xmlns:p="http://schemas.openxmlformats.org/presentationml/2006/main" xmlns:a="http://schemas.openxmlformats.org/drawingml/2006/main">
   <p:cSld>
     <p:bg>
@@ -4632,8 +5005,8 @@
         </p:nvSpPr>
         <p:spPr>
           <a:xfrm rot="0">
-            <a:off x="302818" y="161925"/>
-            <a:ext cx="17682365" cy="9848850"/>
+            <a:off x="302818" y="266700"/>
+            <a:ext cx="17682365" cy="9744075"/>
           </a:xfrm>
           <a:prstGeom prst="rect">
             <a:avLst/>
@@ -4655,10 +5028,10 @@
                 <a:solidFill>
                   <a:srgbClr val="000000"/>
                 </a:solidFill>
-                <a:latin typeface="Jua"/>
-                <a:ea typeface="Jua"/>
-                <a:cs typeface="Jua"/>
-                <a:sym typeface="Jua"/>
+                <a:latin typeface="무궁화 고딕"/>
+                <a:ea typeface="무궁화 고딕"/>
+                <a:cs typeface="무궁화 고딕"/>
+                <a:sym typeface="무궁화 고딕"/>
               </a:rPr>
               <a:t>1 여호와는 나의 목자시니 내게 부족함이 없으리로다</a:t>
             </a:r>
@@ -4681,10 +5054,10 @@
                 <a:solidFill>
                   <a:srgbClr val="000000"/>
                 </a:solidFill>
-                <a:latin typeface="Jua"/>
-                <a:ea typeface="Jua"/>
-                <a:cs typeface="Jua"/>
-                <a:sym typeface="Jua"/>
+                <a:latin typeface="무궁화 고딕"/>
+                <a:ea typeface="무궁화 고딕"/>
+                <a:cs typeface="무궁화 고딕"/>
+                <a:sym typeface="무궁화 고딕"/>
               </a:rPr>
               <a:t>2 그가 나를 푸른 풀밭에 누이시며 쉴 만한 물가로 인도하시는도다</a:t>
             </a:r>
@@ -4707,10 +5080,10 @@
                 <a:solidFill>
                   <a:srgbClr val="000000"/>
                 </a:solidFill>
-                <a:latin typeface="Jua"/>
-                <a:ea typeface="Jua"/>
-                <a:cs typeface="Jua"/>
-                <a:sym typeface="Jua"/>
+                <a:latin typeface="무궁화 고딕"/>
+                <a:ea typeface="무궁화 고딕"/>
+                <a:cs typeface="무궁화 고딕"/>
+                <a:sym typeface="무궁화 고딕"/>
               </a:rPr>
               <a:t>3 내 영혼을 소생시키시고 자기 이름을 위하여 의의 길로 인도하시는도다</a:t>
             </a:r>
@@ -4733,10 +5106,10 @@
                 <a:solidFill>
                   <a:srgbClr val="000000"/>
                 </a:solidFill>
-                <a:latin typeface="Jua"/>
-                <a:ea typeface="Jua"/>
-                <a:cs typeface="Jua"/>
-                <a:sym typeface="Jua"/>
+                <a:latin typeface="무궁화 고딕"/>
+                <a:ea typeface="무궁화 고딕"/>
+                <a:cs typeface="무궁화 고딕"/>
+                <a:sym typeface="무궁화 고딕"/>
               </a:rPr>
               <a:t>4 내가 사망의 음침한 골짜기로 다닐지라도 해를 두려워하지 않을 것은</a:t>
             </a:r>
@@ -4752,10 +5125,10 @@
                 <a:solidFill>
                   <a:srgbClr val="000000"/>
                 </a:solidFill>
-                <a:latin typeface="Jua"/>
-                <a:ea typeface="Jua"/>
-                <a:cs typeface="Jua"/>
-                <a:sym typeface="Jua"/>
+                <a:latin typeface="무궁화 고딕"/>
+                <a:ea typeface="무궁화 고딕"/>
+                <a:cs typeface="무궁화 고딕"/>
+                <a:sym typeface="무궁화 고딕"/>
               </a:rPr>
               <a:t>주께서 나와 함께 하심이라 주의 지팡이와 막대기가 나를 안위하시나이다</a:t>
             </a:r>
@@ -4778,10 +5151,10 @@
                 <a:solidFill>
                   <a:srgbClr val="000000"/>
                 </a:solidFill>
-                <a:latin typeface="Jua"/>
-                <a:ea typeface="Jua"/>
-                <a:cs typeface="Jua"/>
-                <a:sym typeface="Jua"/>
+                <a:latin typeface="무궁화 고딕"/>
+                <a:ea typeface="무궁화 고딕"/>
+                <a:cs typeface="무궁화 고딕"/>
+                <a:sym typeface="무궁화 고딕"/>
               </a:rPr>
               <a:t>5 주께서 내 원수의 목전에서 내게 상을 차려 주시고</a:t>
             </a:r>
@@ -4797,10 +5170,10 @@
                 <a:solidFill>
                   <a:srgbClr val="000000"/>
                 </a:solidFill>
-                <a:latin typeface="Jua"/>
-                <a:ea typeface="Jua"/>
-                <a:cs typeface="Jua"/>
-                <a:sym typeface="Jua"/>
+                <a:latin typeface="무궁화 고딕"/>
+                <a:ea typeface="무궁화 고딕"/>
+                <a:cs typeface="무궁화 고딕"/>
+                <a:sym typeface="무궁화 고딕"/>
               </a:rPr>
               <a:t>기름을 내 머리에 부으셨으니 내 잔이 넘치나이다</a:t>
             </a:r>
@@ -4823,10 +5196,10 @@
                 <a:solidFill>
                   <a:srgbClr val="000000"/>
                 </a:solidFill>
-                <a:latin typeface="Jua"/>
-                <a:ea typeface="Jua"/>
-                <a:cs typeface="Jua"/>
-                <a:sym typeface="Jua"/>
+                <a:latin typeface="무궁화 고딕"/>
+                <a:ea typeface="무궁화 고딕"/>
+                <a:cs typeface="무궁화 고딕"/>
+                <a:sym typeface="무궁화 고딕"/>
               </a:rPr>
               <a:t>6 내 평생에 선하심과 인자하심이 반드시 나를 따르리니</a:t>
             </a:r>
@@ -4842,10 +5215,10 @@
                 <a:solidFill>
                   <a:srgbClr val="000000"/>
                 </a:solidFill>
-                <a:latin typeface="Jua"/>
-                <a:ea typeface="Jua"/>
-                <a:cs typeface="Jua"/>
-                <a:sym typeface="Jua"/>
+                <a:latin typeface="무궁화 고딕"/>
+                <a:ea typeface="무궁화 고딕"/>
+                <a:cs typeface="무궁화 고딕"/>
+                <a:sym typeface="무궁화 고딕"/>
               </a:rPr>
               <a:t>내가 여호와의 집에 영원히 살리로다</a:t>
             </a:r>
@@ -4860,7 +5233,7 @@
 </p:sld>
 </file>
 
-<file path=ppt/slides/slide8.xml><?xml version="1.0" encoding="utf-8"?>
+<file path=ppt/slides/slide9.xml><?xml version="1.0" encoding="utf-8"?>
 <p:sld xmlns:p="http://schemas.openxmlformats.org/presentationml/2006/main" xmlns:a="http://schemas.openxmlformats.org/drawingml/2006/main" xmlns:r="http://schemas.openxmlformats.org/officeDocument/2006/relationships">
   <p:cSld>
     <p:bg>
@@ -4942,8 +5315,8 @@
         </p:nvSpPr>
         <p:spPr>
           <a:xfrm rot="0">
-            <a:off x="2717556" y="2943225"/>
-            <a:ext cx="12852888" cy="4105275"/>
+            <a:off x="2717556" y="3228975"/>
+            <a:ext cx="12852888" cy="3819525"/>
           </a:xfrm>
           <a:prstGeom prst="rect">
             <a:avLst/>
@@ -4965,10 +5338,10 @@
                 <a:solidFill>
                   <a:srgbClr val="000000"/>
                 </a:solidFill>
-                <a:latin typeface="Jua"/>
-                <a:ea typeface="Jua"/>
-                <a:cs typeface="Jua"/>
-                <a:sym typeface="Jua"/>
+                <a:latin typeface="무궁화 고딕"/>
+                <a:ea typeface="무궁화 고딕"/>
+                <a:cs typeface="무궁화 고딕"/>
+                <a:sym typeface="무궁화 고딕"/>
               </a:rPr>
               <a:t>[ 3 Round ] </a:t>
             </a:r>
@@ -4984,10 +5357,10 @@
                 <a:solidFill>
                   <a:srgbClr val="000000"/>
                 </a:solidFill>
-                <a:latin typeface="Jua"/>
-                <a:ea typeface="Jua"/>
-                <a:cs typeface="Jua"/>
-                <a:sym typeface="Jua"/>
+                <a:latin typeface="무궁화 고딕"/>
+                <a:ea typeface="무궁화 고딕"/>
+                <a:cs typeface="무궁화 고딕"/>
+                <a:sym typeface="무궁화 고딕"/>
               </a:rPr>
               <a:t>빌립보</a:t>
             </a:r>
@@ -4996,246 +5369,12 @@
                 <a:solidFill>
                   <a:srgbClr val="000000"/>
                 </a:solidFill>
-                <a:latin typeface="Jua"/>
-                <a:ea typeface="Jua"/>
-                <a:cs typeface="Jua"/>
-                <a:sym typeface="Jua"/>
+                <a:latin typeface="무궁화 고딕"/>
+                <a:ea typeface="무궁화 고딕"/>
+                <a:cs typeface="무궁화 고딕"/>
+                <a:sym typeface="무궁화 고딕"/>
               </a:rPr>
               <a:t>서 4:4-8</a:t>
-            </a:r>
-          </a:p>
-        </p:txBody>
-      </p:sp>
-    </p:spTree>
-  </p:cSld>
-  <p:clrMapOvr>
-    <a:masterClrMapping/>
-  </p:clrMapOvr>
-</p:sld>
-</file>
-
-<file path=ppt/slides/slide9.xml><?xml version="1.0" encoding="utf-8"?>
-<p:sld xmlns:p="http://schemas.openxmlformats.org/presentationml/2006/main" xmlns:a="http://schemas.openxmlformats.org/drawingml/2006/main">
-  <p:cSld>
-    <p:bg>
-      <p:bgPr>
-        <a:solidFill>
-          <a:srgbClr val="FFFAEF"/>
-        </a:solidFill>
-      </p:bgPr>
-    </p:bg>
-    <p:spTree>
-      <p:nvGrpSpPr>
-        <p:cNvPr id="1" name=""/>
-        <p:cNvGrpSpPr/>
-        <p:nvPr/>
-      </p:nvGrpSpPr>
-      <p:grpSpPr>
-        <a:xfrm>
-          <a:off x="0" y="0"/>
-          <a:ext cx="0" cy="0"/>
-          <a:chOff x="0" y="0"/>
-          <a:chExt cx="0" cy="0"/>
-        </a:xfrm>
-      </p:grpSpPr>
-      <p:sp>
-        <p:nvSpPr>
-          <p:cNvPr name="TextBox 2" id="2"/>
-          <p:cNvSpPr txBox="true"/>
-          <p:nvPr/>
-        </p:nvSpPr>
-        <p:spPr>
-          <a:xfrm rot="0">
-            <a:off x="449252" y="200025"/>
-            <a:ext cx="17682365" cy="9772650"/>
-          </a:xfrm>
-          <a:prstGeom prst="rect">
-            <a:avLst/>
-          </a:prstGeom>
-        </p:spPr>
-        <p:txBody>
-          <a:bodyPr anchor="t" rtlCol="false" tIns="0" lIns="0" bIns="0" rIns="0">
-            <a:spAutoFit/>
-          </a:bodyPr>
-          <a:lstStyle/>
-          <a:p>
-            <a:pPr algn="ctr">
-              <a:lnSpc>
-                <a:spcPts val="5879"/>
-              </a:lnSpc>
-            </a:pPr>
-            <a:r>
-              <a:rPr lang="en-US" sz="4899">
-                <a:solidFill>
-                  <a:srgbClr val="000000"/>
-                </a:solidFill>
-                <a:latin typeface="Jua"/>
-                <a:ea typeface="Jua"/>
-                <a:cs typeface="Jua"/>
-                <a:sym typeface="Jua"/>
-              </a:rPr>
-              <a:t>4 주 안에서 항상 기뻐하라 내가 다시 말하노니 기뻐하라</a:t>
-            </a:r>
-          </a:p>
-          <a:p>
-            <a:pPr algn="ctr">
-              <a:lnSpc>
-                <a:spcPts val="5879"/>
-              </a:lnSpc>
-            </a:pPr>
-          </a:p>
-          <a:p>
-            <a:pPr algn="ctr">
-              <a:lnSpc>
-                <a:spcPts val="5879"/>
-              </a:lnSpc>
-            </a:pPr>
-            <a:r>
-              <a:rPr lang="en-US" sz="4899">
-                <a:solidFill>
-                  <a:srgbClr val="000000"/>
-                </a:solidFill>
-                <a:latin typeface="Jua"/>
-                <a:ea typeface="Jua"/>
-                <a:cs typeface="Jua"/>
-                <a:sym typeface="Jua"/>
-              </a:rPr>
-              <a:t>5 너희 관용을 모든 사람에게 알게 하라 주께서 가까우시니라</a:t>
-            </a:r>
-          </a:p>
-          <a:p>
-            <a:pPr algn="ctr">
-              <a:lnSpc>
-                <a:spcPts val="5879"/>
-              </a:lnSpc>
-            </a:pPr>
-          </a:p>
-          <a:p>
-            <a:pPr algn="ctr">
-              <a:lnSpc>
-                <a:spcPts val="5879"/>
-              </a:lnSpc>
-            </a:pPr>
-            <a:r>
-              <a:rPr lang="en-US" sz="4899">
-                <a:solidFill>
-                  <a:srgbClr val="000000"/>
-                </a:solidFill>
-                <a:latin typeface="Jua"/>
-                <a:ea typeface="Jua"/>
-                <a:cs typeface="Jua"/>
-                <a:sym typeface="Jua"/>
-              </a:rPr>
-              <a:t>6 아무 것도 염려하지 말고 다만 모든 일에 기도와 간구로,</a:t>
-            </a:r>
-          </a:p>
-          <a:p>
-            <a:pPr algn="ctr">
-              <a:lnSpc>
-                <a:spcPts val="5879"/>
-              </a:lnSpc>
-            </a:pPr>
-            <a:r>
-              <a:rPr lang="en-US" sz="4899">
-                <a:solidFill>
-                  <a:srgbClr val="000000"/>
-                </a:solidFill>
-                <a:latin typeface="Jua"/>
-                <a:ea typeface="Jua"/>
-                <a:cs typeface="Jua"/>
-                <a:sym typeface="Jua"/>
-              </a:rPr>
-              <a:t>너희 구할 것을 감사함으로 하나님께 아뢰라</a:t>
-            </a:r>
-          </a:p>
-          <a:p>
-            <a:pPr algn="ctr">
-              <a:lnSpc>
-                <a:spcPts val="5879"/>
-              </a:lnSpc>
-            </a:pPr>
-          </a:p>
-          <a:p>
-            <a:pPr algn="ctr">
-              <a:lnSpc>
-                <a:spcPts val="5879"/>
-              </a:lnSpc>
-            </a:pPr>
-            <a:r>
-              <a:rPr lang="en-US" sz="4899">
-                <a:solidFill>
-                  <a:srgbClr val="000000"/>
-                </a:solidFill>
-                <a:latin typeface="Jua"/>
-                <a:ea typeface="Jua"/>
-                <a:cs typeface="Jua"/>
-                <a:sym typeface="Jua"/>
-              </a:rPr>
-              <a:t>7 그리하면 모든 지각에 뛰어난 하나님의 평강이</a:t>
-            </a:r>
-          </a:p>
-          <a:p>
-            <a:pPr algn="ctr">
-              <a:lnSpc>
-                <a:spcPts val="5879"/>
-              </a:lnSpc>
-            </a:pPr>
-            <a:r>
-              <a:rPr lang="en-US" sz="4899">
-                <a:solidFill>
-                  <a:srgbClr val="000000"/>
-                </a:solidFill>
-                <a:latin typeface="Jua"/>
-                <a:ea typeface="Jua"/>
-                <a:cs typeface="Jua"/>
-                <a:sym typeface="Jua"/>
-              </a:rPr>
-              <a:t>그리스도 예수 안에서 너희 마음과 생각을 지키시리라</a:t>
-            </a:r>
-          </a:p>
-          <a:p>
-            <a:pPr algn="ctr">
-              <a:lnSpc>
-                <a:spcPts val="5879"/>
-              </a:lnSpc>
-            </a:pPr>
-          </a:p>
-          <a:p>
-            <a:pPr algn="ctr">
-              <a:lnSpc>
-                <a:spcPts val="5879"/>
-              </a:lnSpc>
-            </a:pPr>
-            <a:r>
-              <a:rPr lang="en-US" sz="4899">
-                <a:solidFill>
-                  <a:srgbClr val="000000"/>
-                </a:solidFill>
-                <a:latin typeface="Jua"/>
-                <a:ea typeface="Jua"/>
-                <a:cs typeface="Jua"/>
-                <a:sym typeface="Jua"/>
-              </a:rPr>
-              <a:t>8 끝으로 형제들아 무엇에든지 참되며 무엇에든지 경건하며 무엇에든지</a:t>
-            </a:r>
-          </a:p>
-          <a:p>
-            <a:pPr algn="ctr">
-              <a:lnSpc>
-                <a:spcPts val="5879"/>
-              </a:lnSpc>
-            </a:pPr>
-            <a:r>
-              <a:rPr lang="en-US" sz="4899">
-                <a:solidFill>
-                  <a:srgbClr val="000000"/>
-                </a:solidFill>
-                <a:latin typeface="Jua"/>
-                <a:ea typeface="Jua"/>
-                <a:cs typeface="Jua"/>
-                <a:sym typeface="Jua"/>
-              </a:rPr>
-              <a:t>옳으며 무엇에든지 정결하며 무엇에든지 사랑받을 만하며 무엇에든지 칭찬받을 만하며 무슨 덕이 있든지 무슨 기림이 있든지 이것들을 생각하라</a:t>
             </a:r>
           </a:p>
         </p:txBody>

</xml_diff>